<commit_message>
Update Telecom Network Outage Analytics presentation
</commit_message>
<xml_diff>
--- a/Telecom_Network_Outage_Analytics/presentation/Telecom Network Outage Analytics.pptx
+++ b/Telecom_Network_Outage_Analytics/presentation/Telecom Network Outage Analytics.pptx
@@ -2838,7 +2838,7 @@
               <c:strCache>
                 <c:ptCount val="1"/>
                 <c:pt idx="0">
-                  <c:v>Hours</c:v>
+                  <c:v>Minutes</c:v>
                 </c:pt>
               </c:strCache>
             </c:strRef>
@@ -8705,7 +8705,7 @@
         <p:spPr>
           <a:xfrm>
             <a:off x="731520" y="4160520"/>
-            <a:ext cx="8686800" cy="457200"/>
+            <a:ext cx="8869680" cy="457200"/>
           </a:xfrm>
           <a:prstGeom prst="rect">
             <a:avLst/>
@@ -8721,7 +8721,7 @@
               <a:buNone/>
             </a:pPr>
             <a:r>
-              <a:rPr lang="en-US" sz="1500" i="1" dirty="0">
+              <a:rPr lang="en-US" sz="1400" i="1" dirty="0">
                 <a:solidFill>
                   <a:srgbClr val="C7D3E8"/>
                 </a:solidFill>
@@ -8729,9 +8729,9 @@
                 <a:ea typeface="Calibri" pitchFamily="34" charset="-122"/>
                 <a:cs typeface="Calibri" pitchFamily="34" charset="-120"/>
               </a:rPr>
-              <a:t>Turning 5,000 outages and 1.08M customer impacts into a targeted reliability roadmap</a:t>
-            </a:r>
-            <a:endParaRPr lang="en-US" sz="1500" dirty="0"/>
+              <a:t>Turning 5,000 outages and 1.08M aggregated customer-impact events into a targeted reliability roadmap</a:t>
+            </a:r>
+            <a:endParaRPr lang="en-US" sz="1400" dirty="0"/>
           </a:p>
         </p:txBody>
       </p:sp>
@@ -8794,6 +8794,45 @@
               <a:t>Business Review  |  FY2024 – FY2025  |  500 Sites  •  5 Vendors  •  12 UK Regions</a:t>
             </a:r>
             <a:endParaRPr lang="en-US" sz="1200" dirty="0"/>
+          </a:p>
+        </p:txBody>
+      </p:sp>
+      <p:sp>
+        <p:nvSpPr>
+          <p:cNvPr id="15" name="Text 13"/>
+          <p:cNvSpPr/>
+          <p:nvPr/>
+        </p:nvSpPr>
+        <p:spPr>
+          <a:xfrm>
+            <a:off x="731520" y="5349240"/>
+            <a:ext cx="8229600" cy="320040"/>
+          </a:xfrm>
+          <a:prstGeom prst="rect">
+            <a:avLst/>
+          </a:prstGeom>
+          <a:noFill/>
+          <a:ln/>
+        </p:spPr>
+        <p:txBody>
+          <a:bodyPr wrap="square" lIns="0" tIns="0" rIns="0" bIns="0" rtlCol="0" anchor="ctr"/>
+          <a:lstStyle/>
+          <a:p>
+            <a:pPr indent="0" marL="0">
+              <a:buNone/>
+            </a:pPr>
+            <a:r>
+              <a:rPr lang="en-US" sz="1150" b="1" dirty="0">
+                <a:solidFill>
+                  <a:srgbClr val="21C5A8"/>
+                </a:solidFill>
+                <a:latin typeface="Calibri" pitchFamily="34" charset="0"/>
+                <a:ea typeface="Calibri" pitchFamily="34" charset="-122"/>
+                <a:cs typeface="Calibri" pitchFamily="34" charset="-120"/>
+              </a:rPr>
+              <a:t>Prepared by Iheanyi Okwara  |  Data Analyst</a:t>
+            </a:r>
+            <a:endParaRPr lang="en-US" sz="1150" dirty="0"/>
           </a:p>
         </p:txBody>
       </p:sp>
@@ -9469,7 +9508,7 @@
                 <a:ea typeface="Cambria" pitchFamily="34" charset="-122"/>
                 <a:cs typeface="Cambria" pitchFamily="34" charset="-120"/>
               </a:rPr>
-              <a:t>Detection Is Fast — Automated Resolution Still Lags</a:t>
+              <a:t>Critical Alarms Surface Later — Auto-Resolution Remains Limited</a:t>
             </a:r>
             <a:endParaRPr lang="en-US" sz="3000" dirty="0"/>
           </a:p>
@@ -11264,7 +11303,7 @@
                 <a:ea typeface="Calibri" pitchFamily="34" charset="-122"/>
                 <a:cs typeface="Calibri" pitchFamily="34" charset="-120"/>
               </a:rPr>
-              <a:t>Avg. Ticket Resolution Time by Priority (hrs)</a:t>
+              <a:t>Avg. Ticket Resolution Time by Priority (min)</a:t>
             </a:r>
             <a:endParaRPr lang="en-US" sz="1200" dirty="0"/>
           </a:p>
@@ -11383,7 +11422,7 @@
                 <a:ea typeface="Calibri" pitchFamily="34" charset="-122"/>
                 <a:cs typeface="Calibri" pitchFamily="34" charset="-120"/>
               </a:rPr>
-              <a:t>High-priority tickets take 46.3 hours to resolve on average — nearly 13x longer than low-priority tickets (3.6 hrs) — and Medium/Medium-High tickets make up 65% of total ticket volume, so this is where resolution-time investment has the widest reach. Complaint channels are evenly split (App, Store, Web, Social, Phone all 393–406), confirming the issue is service reliability itself, not any single contact channel.</a:t>
+              <a:t>High-priority tickets take 46.3 minutes to resolve on average — nearly 13x longer than low-priority tickets (3.6 min) — and Medium/Medium-High tickets make up 65% of total ticket volume, so this is where resolution-time investment has the widest reach. Complaint channels are evenly split (App, Store, Web, Social, Phone all 393–406), suggesting the issue is service reliability itself, not any single contact channel.</a:t>
             </a:r>
             <a:endParaRPr lang="en-US" sz="1200" dirty="0"/>
           </a:p>
@@ -11448,7 +11487,7 @@
                 <a:ea typeface="Calibri" pitchFamily="34" charset="-122"/>
                 <a:cs typeface="Calibri" pitchFamily="34" charset="-120"/>
               </a:rPr>
-              <a:t>Escalation rate climbs with priority (18.9% Low → 20.9% Medium), suggesting current triage isn't fully protecting urgent cases from further escalation.</a:t>
+              <a:t>Escalation rates remain relatively close across priority groups, ranging from 18.9% to 20.9%, suggesting escalation is not concentrated solely among the highest-priority tickets.</a:t>
             </a:r>
             <a:endParaRPr lang="en-US" sz="1050" dirty="0"/>
           </a:p>
@@ -13773,7 +13812,7 @@
                 <a:ea typeface="Cambria" pitchFamily="34" charset="-122"/>
                 <a:cs typeface="Cambria" pitchFamily="34" charset="-120"/>
               </a:rPr>
-              <a:t>A Five-Point Plan to Rebuild SLA Confidence</a:t>
+              <a:t>A Six-Point, Evidence-Based Reliability Plan</a:t>
             </a:r>
             <a:endParaRPr lang="en-US" sz="3000" dirty="0"/>
           </a:p>
@@ -13957,7 +13996,7 @@
                 <a:ea typeface="Calibri" pitchFamily="34" charset="-122"/>
                 <a:cs typeface="Calibri" pitchFamily="34" charset="-120"/>
               </a:rPr>
-              <a:t>Predictive Hardware Refresh</a:t>
+              <a:t>Hardware Reliability &amp; Preventive Intervention</a:t>
             </a:r>
             <a:endParaRPr lang="en-US" sz="1400" dirty="0"/>
           </a:p>
@@ -13999,7 +14038,7 @@
                 <a:ea typeface="Calibri" pitchFamily="34" charset="-122"/>
                 <a:cs typeface="Calibri" pitchFamily="34" charset="-120"/>
               </a:rPr>
-              <a:t>Target the top 20 hardware-failure sites (incl. Lon0136, Sco0052) with condition-based replacement ahead of failure, not after it.</a:t>
+              <a:t>Prioritise repeat-offender sites on both the downtime and customer-impact leaderboards (e.g. Lon0136, Sco0052) for asset-condition assessment and preventive intervention.</a:t>
             </a:r>
             <a:endParaRPr lang="en-US" sz="1100" dirty="0"/>
           </a:p>
@@ -14122,7 +14161,7 @@
                 <a:ea typeface="Calibri" pitchFamily="34" charset="-122"/>
                 <a:cs typeface="Calibri" pitchFamily="34" charset="-120"/>
               </a:rPr>
-              <a:t>Vendor SLA Renegotiation</a:t>
+              <a:t>Outcome-Based Vendor Performance Management</a:t>
             </a:r>
             <a:endParaRPr lang="en-US" sz="1400" dirty="0"/>
           </a:p>
@@ -14164,7 +14203,7 @@
                 <a:ea typeface="Calibri" pitchFamily="34" charset="-122"/>
                 <a:cs typeface="Calibri" pitchFamily="34" charset="-120"/>
               </a:rPr>
-              <a:t>Rebuild Ericsson's contract around time-to-restore and SLA-adherence penalties, not just fault volume; benchmark against Huawei's 18.48% breach rate.</a:t>
+              <a:t>Review Ericsson's SLA performance and contract terms given its 38-min average outage duration and 20.91% breach rate; consider renegotiation if a review confirms underperformance.</a:t>
             </a:r>
             <a:endParaRPr lang="en-US" sz="1100" dirty="0"/>
           </a:p>
@@ -14287,7 +14326,7 @@
                 <a:ea typeface="Calibri" pitchFamily="34" charset="-122"/>
                 <a:cs typeface="Calibri" pitchFamily="34" charset="-120"/>
               </a:rPr>
-              <a:t>Expand AIOps Auto-Remediation</a:t>
+              <a:t>Critical-Alarm Detection &amp; Automation</a:t>
             </a:r>
             <a:endParaRPr lang="en-US" sz="1400" dirty="0"/>
           </a:p>
@@ -14329,7 +14368,7 @@
                 <a:ea typeface="Calibri" pitchFamily="34" charset="-122"/>
                 <a:cs typeface="Calibri" pitchFamily="34" charset="-120"/>
               </a:rPr>
-              <a:t>Invest in automated triage/runbooks to lift the 30.28% alarm auto-resolution rate, prioritizing Critical-severity alarms first.</a:t>
+              <a:t>Invest in automated triage and improved routing to reduce the 11.2-min average time-to-surface for Critical alarms and lift the 30.28% auto-resolution rate.</a:t>
             </a:r>
             <a:endParaRPr lang="en-US" sz="1100" dirty="0"/>
           </a:p>
@@ -14464,7 +14503,7 @@
                 <a:ea typeface="Calibri" pitchFamily="34" charset="-122"/>
                 <a:cs typeface="Calibri" pitchFamily="34" charset="-120"/>
               </a:rPr>
-              <a:t>London Regional Hardening</a:t>
+              <a:t>London Regional Investigation &amp; Remediation</a:t>
             </a:r>
             <a:endParaRPr lang="en-US" sz="1400" dirty="0"/>
           </a:p>
@@ -14506,7 +14545,7 @@
                 <a:ea typeface="Calibri" pitchFamily="34" charset="-122"/>
                 <a:cs typeface="Calibri" pitchFamily="34" charset="-120"/>
               </a:rPr>
-              <a:t>Stand up a dedicated remediation programme for London given its 26% share of outages and 27% share of downtime hours.</a:t>
+              <a:t>Launch a dedicated investigation into London's 26% share of outages and 27% share of downtime — covering site density, asset condition and capacity — then remediate.</a:t>
             </a:r>
             <a:endParaRPr lang="en-US" sz="1100" dirty="0"/>
           </a:p>
@@ -14641,7 +14680,7 @@
                 <a:ea typeface="Calibri" pitchFamily="34" charset="-122"/>
                 <a:cs typeface="Calibri" pitchFamily="34" charset="-120"/>
               </a:rPr>
-              <a:t>Shift the Maintenance Mix</a:t>
+              <a:t>Maintenance Cost &amp; Outcome Efficiency</a:t>
             </a:r>
             <a:endParaRPr lang="en-US" sz="1400" dirty="0"/>
           </a:p>
@@ -14683,7 +14722,7 @@
                 <a:ea typeface="Calibri" pitchFamily="34" charset="-122"/>
                 <a:cs typeface="Calibri" pitchFamily="34" charset="-120"/>
               </a:rPr>
-              <a:t>Grow planned/preventive coverage to reduce reliance on Emergency maintenance, currently the least reliable category at 91.8% completion.</a:t>
+              <a:t>Identify emergency-maintenance work suitable for conversion to planned/preventive activity (91.8% vs 95.1% completion) and set a target after feasibility review.</a:t>
             </a:r>
             <a:endParaRPr lang="en-US" sz="1100" dirty="0"/>
           </a:p>
@@ -14691,37 +14730,214 @@
       </p:sp>
       <p:sp>
         <p:nvSpPr>
-          <p:cNvPr id="31" name="Text 29"/>
-          <p:cNvSpPr/>
-          <p:nvPr/>
-        </p:nvSpPr>
-        <p:spPr>
-          <a:xfrm>
-            <a:off x="457200" y="6473952"/>
-            <a:ext cx="5486400" cy="274320"/>
-          </a:xfrm>
-          <a:prstGeom prst="rect">
-            <a:avLst/>
-          </a:prstGeom>
-          <a:noFill/>
-          <a:ln/>
-        </p:spPr>
-        <p:txBody>
-          <a:bodyPr wrap="square" rtlCol="0" anchor="ctr"/>
-          <a:lstStyle/>
-          <a:p>
-            <a:pPr algn="l" indent="0" marL="0">
-              <a:buNone/>
-            </a:pPr>
-            <a:r>
-              <a:rPr lang="en-US" sz="900" dirty="0">
-                <a:solidFill>
-                  <a:srgbClr val="5B6B82"/>
+          <p:cNvPr id="31" name="Shape 29"/>
+          <p:cNvSpPr/>
+          <p:nvPr/>
+        </p:nvSpPr>
+        <p:spPr>
+          <a:xfrm>
+            <a:off x="8083296" y="4069080"/>
+            <a:ext cx="3566160" cy="2331720"/>
+          </a:xfrm>
+          <a:prstGeom prst="roundRect">
+            <a:avLst>
+              <a:gd name="adj" fmla="val 3137"/>
+            </a:avLst>
+          </a:prstGeom>
+          <a:solidFill>
+            <a:srgbClr val="FFFFFF"/>
+          </a:solidFill>
+          <a:ln w="12700">
+            <a:solidFill>
+              <a:srgbClr val="E1E8F0"/>
+            </a:solidFill>
+            <a:prstDash val="solid"/>
+          </a:ln>
+          <a:effectLst>
+            <a:outerShdw sx="100000" sy="100000" kx="0" ky="0" algn="bl" rotWithShape="0" blurRad="63500" dist="25400" dir="5400000">
+              <a:srgbClr val="1B2A44">
+                <a:alpha val="10000"/>
+              </a:srgbClr>
+            </a:outerShdw>
+          </a:effectLst>
+        </p:spPr>
+      </p:sp>
+      <p:sp>
+        <p:nvSpPr>
+          <p:cNvPr id="32" name="Shape 30"/>
+          <p:cNvSpPr/>
+          <p:nvPr/>
+        </p:nvSpPr>
+        <p:spPr>
+          <a:xfrm>
+            <a:off x="8339328" y="4325112"/>
+            <a:ext cx="457200" cy="457200"/>
+          </a:xfrm>
+          <a:prstGeom prst="ellipse">
+            <a:avLst/>
+          </a:prstGeom>
+          <a:solidFill>
+            <a:srgbClr val="065A82"/>
+          </a:solidFill>
+          <a:ln/>
+        </p:spPr>
+      </p:sp>
+      <p:sp>
+        <p:nvSpPr>
+          <p:cNvPr id="33" name="Text 31"/>
+          <p:cNvSpPr/>
+          <p:nvPr/>
+        </p:nvSpPr>
+        <p:spPr>
+          <a:xfrm>
+            <a:off x="8339328" y="4306824"/>
+            <a:ext cx="457200" cy="457200"/>
+          </a:xfrm>
+          <a:prstGeom prst="rect">
+            <a:avLst/>
+          </a:prstGeom>
+          <a:noFill/>
+          <a:ln/>
+        </p:spPr>
+        <p:txBody>
+          <a:bodyPr wrap="square" lIns="0" tIns="0" rIns="0" bIns="0" rtlCol="0" anchor="ctr"/>
+          <a:lstStyle/>
+          <a:p>
+            <a:pPr algn="ctr" indent="0" marL="0">
+              <a:buNone/>
+            </a:pPr>
+            <a:r>
+              <a:rPr lang="en-US" sz="1500" b="1" dirty="0">
+                <a:solidFill>
+                  <a:srgbClr val="FFFFFF"/>
                 </a:solidFill>
                 <a:latin typeface="Calibri" pitchFamily="34" charset="0"/>
                 <a:ea typeface="Calibri" pitchFamily="34" charset="-122"/>
                 <a:cs typeface="Calibri" pitchFamily="34" charset="-120"/>
               </a:rPr>
+              <a:t>6</a:t>
+            </a:r>
+            <a:endParaRPr lang="en-US" sz="1500" dirty="0"/>
+          </a:p>
+        </p:txBody>
+      </p:sp>
+      <p:sp>
+        <p:nvSpPr>
+          <p:cNvPr id="34" name="Text 32"/>
+          <p:cNvSpPr/>
+          <p:nvPr/>
+        </p:nvSpPr>
+        <p:spPr>
+          <a:xfrm>
+            <a:off x="8339328" y="4937760"/>
+            <a:ext cx="3054096" cy="502920"/>
+          </a:xfrm>
+          <a:prstGeom prst="rect">
+            <a:avLst/>
+          </a:prstGeom>
+          <a:noFill/>
+          <a:ln/>
+        </p:spPr>
+        <p:txBody>
+          <a:bodyPr wrap="square" lIns="0" tIns="0" rIns="0" bIns="0" rtlCol="0" anchor="ctr"/>
+          <a:lstStyle/>
+          <a:p>
+            <a:pPr indent="0" marL="0">
+              <a:lnSpc>
+                <a:spcPts val="1700"/>
+              </a:lnSpc>
+              <a:buNone/>
+            </a:pPr>
+            <a:r>
+              <a:rPr lang="en-US" sz="1400" b="1" dirty="0">
+                <a:solidFill>
+                  <a:srgbClr val="16233D"/>
+                </a:solidFill>
+                <a:latin typeface="Calibri" pitchFamily="34" charset="0"/>
+                <a:ea typeface="Calibri" pitchFamily="34" charset="-122"/>
+                <a:cs typeface="Calibri" pitchFamily="34" charset="-120"/>
+              </a:rPr>
+              <a:t>Formal SLA &amp; Ticket-Workflow Improvement</a:t>
+            </a:r>
+            <a:endParaRPr lang="en-US" sz="1400" dirty="0"/>
+          </a:p>
+        </p:txBody>
+      </p:sp>
+      <p:sp>
+        <p:nvSpPr>
+          <p:cNvPr id="35" name="Text 33"/>
+          <p:cNvSpPr/>
+          <p:nvPr/>
+        </p:nvSpPr>
+        <p:spPr>
+          <a:xfrm>
+            <a:off x="8339328" y="5440680"/>
+            <a:ext cx="3054096" cy="822960"/>
+          </a:xfrm>
+          <a:prstGeom prst="rect">
+            <a:avLst/>
+          </a:prstGeom>
+          <a:noFill/>
+          <a:ln/>
+        </p:spPr>
+        <p:txBody>
+          <a:bodyPr wrap="square" lIns="0" tIns="0" rIns="0" bIns="0" rtlCol="0" anchor="ctr"/>
+          <a:lstStyle/>
+          <a:p>
+            <a:pPr indent="0" marL="0">
+              <a:lnSpc>
+                <a:spcPts val="1500"/>
+              </a:lnSpc>
+              <a:buNone/>
+            </a:pPr>
+            <a:r>
+              <a:rPr lang="en-US" sz="1100" dirty="0">
+                <a:solidFill>
+                  <a:srgbClr val="5B6B82"/>
+                </a:solidFill>
+                <a:latin typeface="Calibri" pitchFamily="34" charset="0"/>
+                <a:ea typeface="Calibri" pitchFamily="34" charset="-122"/>
+                <a:cs typeface="Calibri" pitchFamily="34" charset="-120"/>
+              </a:rPr>
+              <a:t>Target the 674 non-compliant SLA assessments (63% linked to Critical Outages) and streamline high-priority ticket workflows, where resolution time is disproportionate to volume.</a:t>
+            </a:r>
+            <a:endParaRPr lang="en-US" sz="1100" dirty="0"/>
+          </a:p>
+        </p:txBody>
+      </p:sp>
+      <p:sp>
+        <p:nvSpPr>
+          <p:cNvPr id="36" name="Text 34"/>
+          <p:cNvSpPr/>
+          <p:nvPr/>
+        </p:nvSpPr>
+        <p:spPr>
+          <a:xfrm>
+            <a:off x="457200" y="6473952"/>
+            <a:ext cx="5486400" cy="274320"/>
+          </a:xfrm>
+          <a:prstGeom prst="rect">
+            <a:avLst/>
+          </a:prstGeom>
+          <a:noFill/>
+          <a:ln/>
+        </p:spPr>
+        <p:txBody>
+          <a:bodyPr wrap="square" rtlCol="0" anchor="ctr"/>
+          <a:lstStyle/>
+          <a:p>
+            <a:pPr algn="l" indent="0" marL="0">
+              <a:buNone/>
+            </a:pPr>
+            <a:r>
+              <a:rPr lang="en-US" sz="900" dirty="0">
+                <a:solidFill>
+                  <a:srgbClr val="5B6B82"/>
+                </a:solidFill>
+                <a:latin typeface="Calibri" pitchFamily="34" charset="0"/>
+                <a:ea typeface="Calibri" pitchFamily="34" charset="-122"/>
+                <a:cs typeface="Calibri" pitchFamily="34" charset="-120"/>
+              </a:rPr>
               <a:t>14  —  Recommendations</a:t>
             </a:r>
             <a:endParaRPr lang="en-US" sz="900" dirty="0"/>
@@ -14730,7 +14946,7 @@
       </p:sp>
       <p:sp>
         <p:nvSpPr>
-          <p:cNvPr id="32" name="Text 30"/>
+          <p:cNvPr id="37" name="Text 35"/>
           <p:cNvSpPr/>
           <p:nvPr/>
         </p:nvSpPr>
@@ -14864,7 +15080,7 @@
                 <a:ea typeface="Cambria" pitchFamily="34" charset="-122"/>
                 <a:cs typeface="Cambria" pitchFamily="34" charset="-120"/>
               </a:rPr>
-              <a:t>A Phased Path From Quick Wins to Structural Fixes</a:t>
+              <a:t>A Phased Path From Diagnosis to Scaled Improvement</a:t>
             </a:r>
             <a:endParaRPr lang="en-US" sz="3000" dirty="0"/>
           </a:p>
@@ -15054,7 +15270,7 @@
         </p:nvSpPr>
         <p:spPr>
           <a:xfrm>
-            <a:off x="822960" y="1956816"/>
+            <a:off x="822960" y="1920240"/>
             <a:ext cx="3063240" cy="411480"/>
           </a:xfrm>
           <a:prstGeom prst="rect">
@@ -15071,7 +15287,7 @@
               <a:buNone/>
             </a:pPr>
             <a:r>
-              <a:rPr lang="en-US" sz="2000" b="1" dirty="0">
+              <a:rPr lang="en-US" sz="1700" b="1" dirty="0">
                 <a:solidFill>
                   <a:srgbClr val="FFFFFF"/>
                 </a:solidFill>
@@ -15079,9 +15295,9 @@
                 <a:ea typeface="Cambria" pitchFamily="34" charset="-122"/>
                 <a:cs typeface="Cambria" pitchFamily="34" charset="-120"/>
               </a:rPr>
-              <a:t>Stabilize</a:t>
-            </a:r>
-            <a:endParaRPr lang="en-US" sz="2000" dirty="0"/>
+              <a:t>Diagnose &amp; Stabilise</a:t>
+            </a:r>
+            <a:endParaRPr lang="en-US" sz="1700" dirty="0"/>
           </a:p>
         </p:txBody>
       </p:sp>
@@ -15093,8 +15309,8 @@
         </p:nvSpPr>
         <p:spPr>
           <a:xfrm>
-            <a:off x="822960" y="2816352"/>
-            <a:ext cx="109728" cy="109728"/>
+            <a:off x="822960" y="2734056"/>
+            <a:ext cx="100584" cy="100584"/>
           </a:xfrm>
           <a:prstGeom prst="ellipse">
             <a:avLst/>
@@ -15113,8 +15329,8 @@
         </p:nvSpPr>
         <p:spPr>
           <a:xfrm>
-            <a:off x="1051560" y="2697480"/>
-            <a:ext cx="2834640" cy="594360"/>
+            <a:off x="1051560" y="2596896"/>
+            <a:ext cx="2834640" cy="658368"/>
           </a:xfrm>
           <a:prstGeom prst="rect">
             <a:avLst/>
@@ -15128,12 +15344,12 @@
           <a:p>
             <a:pPr indent="0" marL="0">
               <a:lnSpc>
-                <a:spcPts val="1500"/>
+                <a:spcPts val="1350"/>
               </a:lnSpc>
               <a:buNone/>
             </a:pPr>
             <a:r>
-              <a:rPr lang="en-US" sz="1200" dirty="0">
+              <a:rPr lang="en-US" sz="1080" dirty="0">
                 <a:solidFill>
                   <a:srgbClr val="16233D"/>
                 </a:solidFill>
@@ -15141,9 +15357,9 @@
                 <a:ea typeface="Calibri" pitchFamily="34" charset="-122"/>
                 <a:cs typeface="Calibri" pitchFamily="34" charset="-120"/>
               </a:rPr>
-              <a:t>Audit top 10 repeat-offender sites</a:t>
-            </a:r>
-            <a:endParaRPr lang="en-US" sz="1200" dirty="0"/>
+              <a:t>Audit high-impact/repeat-offender sites</a:t>
+            </a:r>
+            <a:endParaRPr lang="en-US" sz="1080" dirty="0"/>
           </a:p>
         </p:txBody>
       </p:sp>
@@ -15155,8 +15371,8 @@
         </p:nvSpPr>
         <p:spPr>
           <a:xfrm>
-            <a:off x="822960" y="3712464"/>
-            <a:ext cx="109728" cy="109728"/>
+            <a:off x="822960" y="3483864"/>
+            <a:ext cx="100584" cy="100584"/>
           </a:xfrm>
           <a:prstGeom prst="ellipse">
             <a:avLst/>
@@ -15175,8 +15391,8 @@
         </p:nvSpPr>
         <p:spPr>
           <a:xfrm>
-            <a:off x="1051560" y="3593592"/>
-            <a:ext cx="2834640" cy="594360"/>
+            <a:off x="1051560" y="3346704"/>
+            <a:ext cx="2834640" cy="658368"/>
           </a:xfrm>
           <a:prstGeom prst="rect">
             <a:avLst/>
@@ -15190,12 +15406,12 @@
           <a:p>
             <a:pPr indent="0" marL="0">
               <a:lnSpc>
-                <a:spcPts val="1500"/>
+                <a:spcPts val="1350"/>
               </a:lnSpc>
               <a:buNone/>
             </a:pPr>
             <a:r>
-              <a:rPr lang="en-US" sz="1200" dirty="0">
+              <a:rPr lang="en-US" sz="1080" dirty="0">
                 <a:solidFill>
                   <a:srgbClr val="16233D"/>
                 </a:solidFill>
@@ -15203,9 +15419,9 @@
                 <a:ea typeface="Calibri" pitchFamily="34" charset="-122"/>
                 <a:cs typeface="Calibri" pitchFamily="34" charset="-120"/>
               </a:rPr>
-              <a:t>Renegotiate Ericsson SLA terms</a:t>
-            </a:r>
-            <a:endParaRPr lang="en-US" sz="1200" dirty="0"/>
+              <a:t>Review Ericsson SLA performance &amp; contract terms</a:t>
+            </a:r>
+            <a:endParaRPr lang="en-US" sz="1080" dirty="0"/>
           </a:p>
         </p:txBody>
       </p:sp>
@@ -15217,8 +15433,8 @@
         </p:nvSpPr>
         <p:spPr>
           <a:xfrm>
-            <a:off x="822960" y="4608576"/>
-            <a:ext cx="109728" cy="109728"/>
+            <a:off x="822960" y="4233672"/>
+            <a:ext cx="100584" cy="100584"/>
           </a:xfrm>
           <a:prstGeom prst="ellipse">
             <a:avLst/>
@@ -15237,8 +15453,8 @@
         </p:nvSpPr>
         <p:spPr>
           <a:xfrm>
-            <a:off x="1051560" y="4489704"/>
-            <a:ext cx="2834640" cy="594360"/>
+            <a:off x="1051560" y="4096512"/>
+            <a:ext cx="2834640" cy="658368"/>
           </a:xfrm>
           <a:prstGeom prst="rect">
             <a:avLst/>
@@ -15252,12 +15468,12 @@
           <a:p>
             <a:pPr indent="0" marL="0">
               <a:lnSpc>
-                <a:spcPts val="1500"/>
+                <a:spcPts val="1350"/>
               </a:lnSpc>
               <a:buNone/>
             </a:pPr>
             <a:r>
-              <a:rPr lang="en-US" sz="1200" dirty="0">
+              <a:rPr lang="en-US" sz="1080" dirty="0">
                 <a:solidFill>
                   <a:srgbClr val="16233D"/>
                 </a:solidFill>
@@ -15265,15 +15481,77 @@
                 <a:ea typeface="Calibri" pitchFamily="34" charset="-122"/>
                 <a:cs typeface="Calibri" pitchFamily="34" charset="-120"/>
               </a:rPr>
-              <a:t>Stand up London incident task force</a:t>
-            </a:r>
-            <a:endParaRPr lang="en-US" sz="1200" dirty="0"/>
+              <a:t>Launch detailed London root-cause investigation</a:t>
+            </a:r>
+            <a:endParaRPr lang="en-US" sz="1080" dirty="0"/>
           </a:p>
         </p:txBody>
       </p:sp>
       <p:sp>
         <p:nvSpPr>
           <p:cNvPr id="17" name="Shape 15"/>
+          <p:cNvSpPr/>
+          <p:nvPr/>
+        </p:nvSpPr>
+        <p:spPr>
+          <a:xfrm>
+            <a:off x="822960" y="4983480"/>
+            <a:ext cx="100584" cy="100584"/>
+          </a:xfrm>
+          <a:prstGeom prst="ellipse">
+            <a:avLst/>
+          </a:prstGeom>
+          <a:solidFill>
+            <a:srgbClr val="065A82"/>
+          </a:solidFill>
+          <a:ln/>
+        </p:spPr>
+      </p:sp>
+      <p:sp>
+        <p:nvSpPr>
+          <p:cNvPr id="18" name="Text 16"/>
+          <p:cNvSpPr/>
+          <p:nvPr/>
+        </p:nvSpPr>
+        <p:spPr>
+          <a:xfrm>
+            <a:off x="1051560" y="4846320"/>
+            <a:ext cx="2834640" cy="658368"/>
+          </a:xfrm>
+          <a:prstGeom prst="rect">
+            <a:avLst/>
+          </a:prstGeom>
+          <a:noFill/>
+          <a:ln/>
+        </p:spPr>
+        <p:txBody>
+          <a:bodyPr wrap="square" lIns="0" tIns="0" rIns="0" bIns="0" rtlCol="0" anchor="ctr"/>
+          <a:lstStyle/>
+          <a:p>
+            <a:pPr indent="0" marL="0">
+              <a:lnSpc>
+                <a:spcPts val="1350"/>
+              </a:lnSpc>
+              <a:buNone/>
+            </a:pPr>
+            <a:r>
+              <a:rPr lang="en-US" sz="1080" dirty="0">
+                <a:solidFill>
+                  <a:srgbClr val="16233D"/>
+                </a:solidFill>
+                <a:latin typeface="Calibri" pitchFamily="34" charset="0"/>
+                <a:ea typeface="Calibri" pitchFamily="34" charset="-122"/>
+                <a:cs typeface="Calibri" pitchFamily="34" charset="-120"/>
+              </a:rPr>
+              <a:t>Review Critical-alarm routing and thresholds</a:t>
+            </a:r>
+            <a:endParaRPr lang="en-US" sz="1080" dirty="0"/>
+          </a:p>
+        </p:txBody>
+      </p:sp>
+      <p:sp>
+        <p:nvSpPr>
+          <p:cNvPr id="19" name="Shape 17"/>
           <p:cNvSpPr/>
           <p:nvPr/>
         </p:nvSpPr>
@@ -15307,7 +15585,7 @@
       </p:sp>
       <p:sp>
         <p:nvSpPr>
-          <p:cNvPr id="18" name="Shape 16"/>
+          <p:cNvPr id="20" name="Shape 18"/>
           <p:cNvSpPr/>
           <p:nvPr/>
         </p:nvSpPr>
@@ -15329,7 +15607,7 @@
       </p:sp>
       <p:sp>
         <p:nvSpPr>
-          <p:cNvPr id="19" name="Shape 17"/>
+          <p:cNvPr id="21" name="Shape 19"/>
           <p:cNvSpPr/>
           <p:nvPr/>
         </p:nvSpPr>
@@ -15349,7 +15627,7 @@
       </p:sp>
       <p:sp>
         <p:nvSpPr>
-          <p:cNvPr id="20" name="Text 18"/>
+          <p:cNvPr id="22" name="Text 20"/>
           <p:cNvSpPr/>
           <p:nvPr/>
         </p:nvSpPr>
@@ -15388,13 +15666,13 @@
       </p:sp>
       <p:sp>
         <p:nvSpPr>
-          <p:cNvPr id="21" name="Text 19"/>
-          <p:cNvSpPr/>
-          <p:nvPr/>
-        </p:nvSpPr>
-        <p:spPr>
-          <a:xfrm>
-            <a:off x="4617720" y="1956816"/>
+          <p:cNvPr id="23" name="Text 21"/>
+          <p:cNvSpPr/>
+          <p:nvPr/>
+        </p:nvSpPr>
+        <p:spPr>
+          <a:xfrm>
+            <a:off x="4617720" y="1920240"/>
             <a:ext cx="3063240" cy="411480"/>
           </a:xfrm>
           <a:prstGeom prst="rect">
@@ -15411,7 +15689,7 @@
               <a:buNone/>
             </a:pPr>
             <a:r>
-              <a:rPr lang="en-US" sz="2000" b="1" dirty="0">
+              <a:rPr lang="en-US" sz="1700" b="1" dirty="0">
                 <a:solidFill>
                   <a:srgbClr val="FFFFFF"/>
                 </a:solidFill>
@@ -15419,22 +15697,22 @@
                 <a:ea typeface="Cambria" pitchFamily="34" charset="-122"/>
                 <a:cs typeface="Cambria" pitchFamily="34" charset="-120"/>
               </a:rPr>
-              <a:t>Automate</a:t>
-            </a:r>
-            <a:endParaRPr lang="en-US" sz="2000" dirty="0"/>
-          </a:p>
-        </p:txBody>
-      </p:sp>
-      <p:sp>
-        <p:nvSpPr>
-          <p:cNvPr id="22" name="Shape 20"/>
-          <p:cNvSpPr/>
-          <p:nvPr/>
-        </p:nvSpPr>
-        <p:spPr>
-          <a:xfrm>
-            <a:off x="4617720" y="2816352"/>
-            <a:ext cx="109728" cy="109728"/>
+              <a:t>Pilot &amp; Improve</a:t>
+            </a:r>
+            <a:endParaRPr lang="en-US" sz="1700" dirty="0"/>
+          </a:p>
+        </p:txBody>
+      </p:sp>
+      <p:sp>
+        <p:nvSpPr>
+          <p:cNvPr id="24" name="Shape 22"/>
+          <p:cNvSpPr/>
+          <p:nvPr/>
+        </p:nvSpPr>
+        <p:spPr>
+          <a:xfrm>
+            <a:off x="4617720" y="2734056"/>
+            <a:ext cx="100584" cy="100584"/>
           </a:xfrm>
           <a:prstGeom prst="ellipse">
             <a:avLst/>
@@ -15447,14 +15725,14 @@
       </p:sp>
       <p:sp>
         <p:nvSpPr>
-          <p:cNvPr id="23" name="Text 21"/>
-          <p:cNvSpPr/>
-          <p:nvPr/>
-        </p:nvSpPr>
-        <p:spPr>
-          <a:xfrm>
-            <a:off x="4846320" y="2697480"/>
-            <a:ext cx="2834640" cy="594360"/>
+          <p:cNvPr id="25" name="Text 23"/>
+          <p:cNvSpPr/>
+          <p:nvPr/>
+        </p:nvSpPr>
+        <p:spPr>
+          <a:xfrm>
+            <a:off x="4846320" y="2596896"/>
+            <a:ext cx="2834640" cy="658368"/>
           </a:xfrm>
           <a:prstGeom prst="rect">
             <a:avLst/>
@@ -15468,12 +15746,12 @@
           <a:p>
             <a:pPr indent="0" marL="0">
               <a:lnSpc>
-                <a:spcPts val="1500"/>
+                <a:spcPts val="1350"/>
               </a:lnSpc>
               <a:buNone/>
             </a:pPr>
             <a:r>
-              <a:rPr lang="en-US" sz="1200" dirty="0">
+              <a:rPr lang="en-US" sz="1080" dirty="0">
                 <a:solidFill>
                   <a:srgbClr val="16233D"/>
                 </a:solidFill>
@@ -15481,22 +15759,22 @@
                 <a:ea typeface="Calibri" pitchFamily="34" charset="-122"/>
                 <a:cs typeface="Calibri" pitchFamily="34" charset="-120"/>
               </a:rPr>
-              <a:t>Deploy AIOps auto-remediation pilots</a:t>
-            </a:r>
-            <a:endParaRPr lang="en-US" sz="1200" dirty="0"/>
-          </a:p>
-        </p:txBody>
-      </p:sp>
-      <p:sp>
-        <p:nvSpPr>
-          <p:cNvPr id="24" name="Shape 22"/>
-          <p:cNvSpPr/>
-          <p:nvPr/>
-        </p:nvSpPr>
-        <p:spPr>
-          <a:xfrm>
-            <a:off x="4617720" y="3712464"/>
-            <a:ext cx="109728" cy="109728"/>
+              <a:t>Pilot automated alarm triage/remediation</a:t>
+            </a:r>
+            <a:endParaRPr lang="en-US" sz="1080" dirty="0"/>
+          </a:p>
+        </p:txBody>
+      </p:sp>
+      <p:sp>
+        <p:nvSpPr>
+          <p:cNvPr id="26" name="Shape 24"/>
+          <p:cNvSpPr/>
+          <p:nvPr/>
+        </p:nvSpPr>
+        <p:spPr>
+          <a:xfrm>
+            <a:off x="4617720" y="3483864"/>
+            <a:ext cx="100584" cy="100584"/>
           </a:xfrm>
           <a:prstGeom prst="ellipse">
             <a:avLst/>
@@ -15509,14 +15787,14 @@
       </p:sp>
       <p:sp>
         <p:nvSpPr>
-          <p:cNvPr id="25" name="Text 23"/>
-          <p:cNvSpPr/>
-          <p:nvPr/>
-        </p:nvSpPr>
-        <p:spPr>
-          <a:xfrm>
-            <a:off x="4846320" y="3593592"/>
-            <a:ext cx="2834640" cy="594360"/>
+          <p:cNvPr id="27" name="Text 25"/>
+          <p:cNvSpPr/>
+          <p:nvPr/>
+        </p:nvSpPr>
+        <p:spPr>
+          <a:xfrm>
+            <a:off x="4846320" y="3346704"/>
+            <a:ext cx="2834640" cy="658368"/>
           </a:xfrm>
           <a:prstGeom prst="rect">
             <a:avLst/>
@@ -15530,12 +15808,12 @@
           <a:p>
             <a:pPr indent="0" marL="0">
               <a:lnSpc>
-                <a:spcPts val="1500"/>
+                <a:spcPts val="1350"/>
               </a:lnSpc>
               <a:buNone/>
             </a:pPr>
             <a:r>
-              <a:rPr lang="en-US" sz="1200" dirty="0">
+              <a:rPr lang="en-US" sz="1080" dirty="0">
                 <a:solidFill>
                   <a:srgbClr val="16233D"/>
                 </a:solidFill>
@@ -15543,22 +15821,22 @@
                 <a:ea typeface="Calibri" pitchFamily="34" charset="-122"/>
                 <a:cs typeface="Calibri" pitchFamily="34" charset="-120"/>
               </a:rPr>
-              <a:t>Re-tune critical alarm thresholds</a:t>
-            </a:r>
-            <a:endParaRPr lang="en-US" sz="1200" dirty="0"/>
-          </a:p>
-        </p:txBody>
-      </p:sp>
-      <p:sp>
-        <p:nvSpPr>
-          <p:cNvPr id="26" name="Shape 24"/>
-          <p:cNvSpPr/>
-          <p:nvPr/>
-        </p:nvSpPr>
-        <p:spPr>
-          <a:xfrm>
-            <a:off x="4617720" y="4608576"/>
-            <a:ext cx="109728" cy="109728"/>
+              <a:t>Implement vendor performance scorecards</a:t>
+            </a:r>
+            <a:endParaRPr lang="en-US" sz="1080" dirty="0"/>
+          </a:p>
+        </p:txBody>
+      </p:sp>
+      <p:sp>
+        <p:nvSpPr>
+          <p:cNvPr id="28" name="Shape 26"/>
+          <p:cNvSpPr/>
+          <p:nvPr/>
+        </p:nvSpPr>
+        <p:spPr>
+          <a:xfrm>
+            <a:off x="4617720" y="4233672"/>
+            <a:ext cx="100584" cy="100584"/>
           </a:xfrm>
           <a:prstGeom prst="ellipse">
             <a:avLst/>
@@ -15571,14 +15849,14 @@
       </p:sp>
       <p:sp>
         <p:nvSpPr>
-          <p:cNvPr id="27" name="Text 25"/>
-          <p:cNvSpPr/>
-          <p:nvPr/>
-        </p:nvSpPr>
-        <p:spPr>
-          <a:xfrm>
-            <a:off x="4846320" y="4489704"/>
-            <a:ext cx="2834640" cy="594360"/>
+          <p:cNvPr id="29" name="Text 27"/>
+          <p:cNvSpPr/>
+          <p:nvPr/>
+        </p:nvSpPr>
+        <p:spPr>
+          <a:xfrm>
+            <a:off x="4846320" y="4096512"/>
+            <a:ext cx="2834640" cy="658368"/>
           </a:xfrm>
           <a:prstGeom prst="rect">
             <a:avLst/>
@@ -15592,12 +15870,12 @@
           <a:p>
             <a:pPr indent="0" marL="0">
               <a:lnSpc>
-                <a:spcPts val="1500"/>
+                <a:spcPts val="1350"/>
               </a:lnSpc>
               <a:buNone/>
             </a:pPr>
             <a:r>
-              <a:rPr lang="en-US" sz="1200" dirty="0">
+              <a:rPr lang="en-US" sz="1080" dirty="0">
                 <a:solidFill>
                   <a:srgbClr val="16233D"/>
                 </a:solidFill>
@@ -15605,15 +15883,77 @@
                 <a:ea typeface="Calibri" pitchFamily="34" charset="-122"/>
                 <a:cs typeface="Calibri" pitchFamily="34" charset="-120"/>
               </a:rPr>
-              <a:t>Shift 10% of emergency work to planned</a:t>
-            </a:r>
-            <a:endParaRPr lang="en-US" sz="1200" dirty="0"/>
-          </a:p>
-        </p:txBody>
-      </p:sp>
-      <p:sp>
-        <p:nvSpPr>
-          <p:cNvPr id="28" name="Shape 26"/>
+              <a:t>Pilot targeted preventive maintenance at high-risk sites</a:t>
+            </a:r>
+            <a:endParaRPr lang="en-US" sz="1080" dirty="0"/>
+          </a:p>
+        </p:txBody>
+      </p:sp>
+      <p:sp>
+        <p:nvSpPr>
+          <p:cNvPr id="30" name="Shape 28"/>
+          <p:cNvSpPr/>
+          <p:nvPr/>
+        </p:nvSpPr>
+        <p:spPr>
+          <a:xfrm>
+            <a:off x="4617720" y="4983480"/>
+            <a:ext cx="100584" cy="100584"/>
+          </a:xfrm>
+          <a:prstGeom prst="ellipse">
+            <a:avLst/>
+          </a:prstGeom>
+          <a:solidFill>
+            <a:srgbClr val="1C7293"/>
+          </a:solidFill>
+          <a:ln/>
+        </p:spPr>
+      </p:sp>
+      <p:sp>
+        <p:nvSpPr>
+          <p:cNvPr id="31" name="Text 29"/>
+          <p:cNvSpPr/>
+          <p:nvPr/>
+        </p:nvSpPr>
+        <p:spPr>
+          <a:xfrm>
+            <a:off x="4846320" y="4846320"/>
+            <a:ext cx="2834640" cy="658368"/>
+          </a:xfrm>
+          <a:prstGeom prst="rect">
+            <a:avLst/>
+          </a:prstGeom>
+          <a:noFill/>
+          <a:ln/>
+        </p:spPr>
+        <p:txBody>
+          <a:bodyPr wrap="square" lIns="0" tIns="0" rIns="0" bIns="0" rtlCol="0" anchor="ctr"/>
+          <a:lstStyle/>
+          <a:p>
+            <a:pPr indent="0" marL="0">
+              <a:lnSpc>
+                <a:spcPts val="1350"/>
+              </a:lnSpc>
+              <a:buNone/>
+            </a:pPr>
+            <a:r>
+              <a:rPr lang="en-US" sz="1080" dirty="0">
+                <a:solidFill>
+                  <a:srgbClr val="16233D"/>
+                </a:solidFill>
+                <a:latin typeface="Calibri" pitchFamily="34" charset="0"/>
+                <a:ea typeface="Calibri" pitchFamily="34" charset="-122"/>
+                <a:cs typeface="Calibri" pitchFamily="34" charset="-120"/>
+              </a:rPr>
+              <a:t>Identify emergency work suitable for conversion to planned</a:t>
+            </a:r>
+            <a:endParaRPr lang="en-US" sz="1080" dirty="0"/>
+          </a:p>
+        </p:txBody>
+      </p:sp>
+      <p:sp>
+        <p:nvSpPr>
+          <p:cNvPr id="32" name="Shape 30"/>
           <p:cNvSpPr/>
           <p:nvPr/>
         </p:nvSpPr>
@@ -15647,7 +15987,7 @@
       </p:sp>
       <p:sp>
         <p:nvSpPr>
-          <p:cNvPr id="29" name="Shape 27"/>
+          <p:cNvPr id="33" name="Shape 31"/>
           <p:cNvSpPr/>
           <p:nvPr/>
         </p:nvSpPr>
@@ -15669,7 +16009,7 @@
       </p:sp>
       <p:sp>
         <p:nvSpPr>
-          <p:cNvPr id="30" name="Shape 28"/>
+          <p:cNvPr id="34" name="Shape 32"/>
           <p:cNvSpPr/>
           <p:nvPr/>
         </p:nvSpPr>
@@ -15689,7 +16029,7 @@
       </p:sp>
       <p:sp>
         <p:nvSpPr>
-          <p:cNvPr id="31" name="Text 29"/>
+          <p:cNvPr id="35" name="Text 33"/>
           <p:cNvSpPr/>
           <p:nvPr/>
         </p:nvSpPr>
@@ -15728,13 +16068,13 @@
       </p:sp>
       <p:sp>
         <p:nvSpPr>
-          <p:cNvPr id="32" name="Text 30"/>
-          <p:cNvSpPr/>
-          <p:nvPr/>
-        </p:nvSpPr>
-        <p:spPr>
-          <a:xfrm>
-            <a:off x="8412480" y="1956816"/>
+          <p:cNvPr id="36" name="Text 34"/>
+          <p:cNvSpPr/>
+          <p:nvPr/>
+        </p:nvSpPr>
+        <p:spPr>
+          <a:xfrm>
+            <a:off x="8412480" y="1920240"/>
             <a:ext cx="3063240" cy="411480"/>
           </a:xfrm>
           <a:prstGeom prst="rect">
@@ -15751,7 +16091,7 @@
               <a:buNone/>
             </a:pPr>
             <a:r>
-              <a:rPr lang="en-US" sz="2000" b="1" dirty="0">
+              <a:rPr lang="en-US" sz="1700" b="1" dirty="0">
                 <a:solidFill>
                   <a:srgbClr val="FFFFFF"/>
                 </a:solidFill>
@@ -15759,22 +16099,22 @@
                 <a:ea typeface="Cambria" pitchFamily="34" charset="-122"/>
                 <a:cs typeface="Cambria" pitchFamily="34" charset="-120"/>
               </a:rPr>
-              <a:t>Transform</a:t>
-            </a:r>
-            <a:endParaRPr lang="en-US" sz="2000" dirty="0"/>
-          </a:p>
-        </p:txBody>
-      </p:sp>
-      <p:sp>
-        <p:nvSpPr>
-          <p:cNvPr id="33" name="Shape 31"/>
-          <p:cNvSpPr/>
-          <p:nvPr/>
-        </p:nvSpPr>
-        <p:spPr>
-          <a:xfrm>
-            <a:off x="8412480" y="2816352"/>
-            <a:ext cx="109728" cy="109728"/>
+              <a:t>Scale &amp; Optimise</a:t>
+            </a:r>
+            <a:endParaRPr lang="en-US" sz="1700" dirty="0"/>
+          </a:p>
+        </p:txBody>
+      </p:sp>
+      <p:sp>
+        <p:nvSpPr>
+          <p:cNvPr id="37" name="Shape 35"/>
+          <p:cNvSpPr/>
+          <p:nvPr/>
+        </p:nvSpPr>
+        <p:spPr>
+          <a:xfrm>
+            <a:off x="8412480" y="2734056"/>
+            <a:ext cx="100584" cy="100584"/>
           </a:xfrm>
           <a:prstGeom prst="ellipse">
             <a:avLst/>
@@ -15787,14 +16127,14 @@
       </p:sp>
       <p:sp>
         <p:nvSpPr>
-          <p:cNvPr id="34" name="Text 32"/>
-          <p:cNvSpPr/>
-          <p:nvPr/>
-        </p:nvSpPr>
-        <p:spPr>
-          <a:xfrm>
-            <a:off x="8641080" y="2697480"/>
-            <a:ext cx="2834640" cy="594360"/>
+          <p:cNvPr id="38" name="Text 36"/>
+          <p:cNvSpPr/>
+          <p:nvPr/>
+        </p:nvSpPr>
+        <p:spPr>
+          <a:xfrm>
+            <a:off x="8641080" y="2596896"/>
+            <a:ext cx="2834640" cy="658368"/>
           </a:xfrm>
           <a:prstGeom prst="rect">
             <a:avLst/>
@@ -15808,12 +16148,12 @@
           <a:p>
             <a:pPr indent="0" marL="0">
               <a:lnSpc>
-                <a:spcPts val="1500"/>
+                <a:spcPts val="1350"/>
               </a:lnSpc>
               <a:buNone/>
             </a:pPr>
             <a:r>
-              <a:rPr lang="en-US" sz="1200" dirty="0">
+              <a:rPr lang="en-US" sz="1080" dirty="0">
                 <a:solidFill>
                   <a:srgbClr val="16233D"/>
                 </a:solidFill>
@@ -15821,22 +16161,22 @@
                 <a:ea typeface="Calibri" pitchFamily="34" charset="-122"/>
                 <a:cs typeface="Calibri" pitchFamily="34" charset="-120"/>
               </a:rPr>
-              <a:t>Complete hardware refresh at hotspot sites</a:t>
-            </a:r>
-            <a:endParaRPr lang="en-US" sz="1200" dirty="0"/>
-          </a:p>
-        </p:txBody>
-      </p:sp>
-      <p:sp>
-        <p:nvSpPr>
-          <p:cNvPr id="35" name="Shape 33"/>
-          <p:cNvSpPr/>
-          <p:nvPr/>
-        </p:nvSpPr>
-        <p:spPr>
-          <a:xfrm>
-            <a:off x="8412480" y="3712464"/>
-            <a:ext cx="109728" cy="109728"/>
+              <a:t>Scale successful hardware reliability interventions</a:t>
+            </a:r>
+            <a:endParaRPr lang="en-US" sz="1080" dirty="0"/>
+          </a:p>
+        </p:txBody>
+      </p:sp>
+      <p:sp>
+        <p:nvSpPr>
+          <p:cNvPr id="39" name="Shape 37"/>
+          <p:cNvSpPr/>
+          <p:nvPr/>
+        </p:nvSpPr>
+        <p:spPr>
+          <a:xfrm>
+            <a:off x="8412480" y="3483864"/>
+            <a:ext cx="100584" cy="100584"/>
           </a:xfrm>
           <a:prstGeom prst="ellipse">
             <a:avLst/>
@@ -15849,14 +16189,14 @@
       </p:sp>
       <p:sp>
         <p:nvSpPr>
-          <p:cNvPr id="36" name="Text 34"/>
-          <p:cNvSpPr/>
-          <p:nvPr/>
-        </p:nvSpPr>
-        <p:spPr>
-          <a:xfrm>
-            <a:off x="8641080" y="3593592"/>
-            <a:ext cx="2834640" cy="594360"/>
+          <p:cNvPr id="40" name="Text 38"/>
+          <p:cNvSpPr/>
+          <p:nvPr/>
+        </p:nvSpPr>
+        <p:spPr>
+          <a:xfrm>
+            <a:off x="8641080" y="3346704"/>
+            <a:ext cx="2834640" cy="658368"/>
           </a:xfrm>
           <a:prstGeom prst="rect">
             <a:avLst/>
@@ -15870,12 +16210,12 @@
           <a:p>
             <a:pPr indent="0" marL="0">
               <a:lnSpc>
-                <a:spcPts val="1500"/>
+                <a:spcPts val="1350"/>
               </a:lnSpc>
               <a:buNone/>
             </a:pPr>
             <a:r>
-              <a:rPr lang="en-US" sz="1200" dirty="0">
+              <a:rPr lang="en-US" sz="1080" dirty="0">
                 <a:solidFill>
                   <a:srgbClr val="16233D"/>
                 </a:solidFill>
@@ -15885,20 +16225,20 @@
               </a:rPr>
               <a:t>Roll out vendor scorecards network-wide</a:t>
             </a:r>
-            <a:endParaRPr lang="en-US" sz="1200" dirty="0"/>
-          </a:p>
-        </p:txBody>
-      </p:sp>
-      <p:sp>
-        <p:nvSpPr>
-          <p:cNvPr id="37" name="Shape 35"/>
-          <p:cNvSpPr/>
-          <p:nvPr/>
-        </p:nvSpPr>
-        <p:spPr>
-          <a:xfrm>
-            <a:off x="8412480" y="4608576"/>
-            <a:ext cx="109728" cy="109728"/>
+            <a:endParaRPr lang="en-US" sz="1080" dirty="0"/>
+          </a:p>
+        </p:txBody>
+      </p:sp>
+      <p:sp>
+        <p:nvSpPr>
+          <p:cNvPr id="41" name="Shape 39"/>
+          <p:cNvSpPr/>
+          <p:nvPr/>
+        </p:nvSpPr>
+        <p:spPr>
+          <a:xfrm>
+            <a:off x="8412480" y="4233672"/>
+            <a:ext cx="100584" cy="100584"/>
           </a:xfrm>
           <a:prstGeom prst="ellipse">
             <a:avLst/>
@@ -15911,14 +16251,14 @@
       </p:sp>
       <p:sp>
         <p:nvSpPr>
-          <p:cNvPr id="38" name="Text 36"/>
-          <p:cNvSpPr/>
-          <p:nvPr/>
-        </p:nvSpPr>
-        <p:spPr>
-          <a:xfrm>
-            <a:off x="8641080" y="4489704"/>
-            <a:ext cx="2834640" cy="594360"/>
+          <p:cNvPr id="42" name="Text 40"/>
+          <p:cNvSpPr/>
+          <p:nvPr/>
+        </p:nvSpPr>
+        <p:spPr>
+          <a:xfrm>
+            <a:off x="8641080" y="4096512"/>
+            <a:ext cx="2834640" cy="658368"/>
           </a:xfrm>
           <a:prstGeom prst="rect">
             <a:avLst/>
@@ -15932,12 +16272,12 @@
           <a:p>
             <a:pPr indent="0" marL="0">
               <a:lnSpc>
-                <a:spcPts val="1500"/>
+                <a:spcPts val="1350"/>
               </a:lnSpc>
               <a:buNone/>
             </a:pPr>
             <a:r>
-              <a:rPr lang="en-US" sz="1200" dirty="0">
+              <a:rPr lang="en-US" sz="1080" dirty="0">
                 <a:solidFill>
                   <a:srgbClr val="16233D"/>
                 </a:solidFill>
@@ -15945,45 +16285,107 @@
                 <a:ea typeface="Calibri" pitchFamily="34" charset="-122"/>
                 <a:cs typeface="Calibri" pitchFamily="34" charset="-120"/>
               </a:rPr>
-              <a:t>Re-baseline SLA targets on new data</a:t>
-            </a:r>
-            <a:endParaRPr lang="en-US" sz="1200" dirty="0"/>
-          </a:p>
-        </p:txBody>
-      </p:sp>
-      <p:sp>
-        <p:nvSpPr>
-          <p:cNvPr id="39" name="Text 37"/>
-          <p:cNvSpPr/>
-          <p:nvPr/>
-        </p:nvSpPr>
-        <p:spPr>
-          <a:xfrm>
-            <a:off x="457200" y="6473952"/>
-            <a:ext cx="5486400" cy="274320"/>
-          </a:xfrm>
-          <a:prstGeom prst="rect">
-            <a:avLst/>
-          </a:prstGeom>
-          <a:noFill/>
-          <a:ln/>
-        </p:spPr>
-        <p:txBody>
-          <a:bodyPr wrap="square" rtlCol="0" anchor="ctr"/>
-          <a:lstStyle/>
-          <a:p>
-            <a:pPr algn="l" indent="0" marL="0">
-              <a:buNone/>
-            </a:pPr>
-            <a:r>
-              <a:rPr lang="en-US" sz="900" dirty="0">
-                <a:solidFill>
-                  <a:srgbClr val="5B6B82"/>
+              <a:t>Expand proven alarm automation</a:t>
+            </a:r>
+            <a:endParaRPr lang="en-US" sz="1080" dirty="0"/>
+          </a:p>
+        </p:txBody>
+      </p:sp>
+      <p:sp>
+        <p:nvSpPr>
+          <p:cNvPr id="43" name="Shape 41"/>
+          <p:cNvSpPr/>
+          <p:nvPr/>
+        </p:nvSpPr>
+        <p:spPr>
+          <a:xfrm>
+            <a:off x="8412480" y="4983480"/>
+            <a:ext cx="100584" cy="100584"/>
+          </a:xfrm>
+          <a:prstGeom prst="ellipse">
+            <a:avLst/>
+          </a:prstGeom>
+          <a:solidFill>
+            <a:srgbClr val="21C5A8"/>
+          </a:solidFill>
+          <a:ln/>
+        </p:spPr>
+      </p:sp>
+      <p:sp>
+        <p:nvSpPr>
+          <p:cNvPr id="44" name="Text 42"/>
+          <p:cNvSpPr/>
+          <p:nvPr/>
+        </p:nvSpPr>
+        <p:spPr>
+          <a:xfrm>
+            <a:off x="8641080" y="4846320"/>
+            <a:ext cx="2834640" cy="658368"/>
+          </a:xfrm>
+          <a:prstGeom prst="rect">
+            <a:avLst/>
+          </a:prstGeom>
+          <a:noFill/>
+          <a:ln/>
+        </p:spPr>
+        <p:txBody>
+          <a:bodyPr wrap="square" lIns="0" tIns="0" rIns="0" bIns="0" rtlCol="0" anchor="ctr"/>
+          <a:lstStyle/>
+          <a:p>
+            <a:pPr indent="0" marL="0">
+              <a:lnSpc>
+                <a:spcPts val="1350"/>
+              </a:lnSpc>
+              <a:buNone/>
+            </a:pPr>
+            <a:r>
+              <a:rPr lang="en-US" sz="1080" dirty="0">
+                <a:solidFill>
+                  <a:srgbClr val="16233D"/>
                 </a:solidFill>
                 <a:latin typeface="Calibri" pitchFamily="34" charset="0"/>
                 <a:ea typeface="Calibri" pitchFamily="34" charset="-122"/>
                 <a:cs typeface="Calibri" pitchFamily="34" charset="-120"/>
               </a:rPr>
+              <a:t>Re-baseline SLA &amp; maintenance targets on new data</a:t>
+            </a:r>
+            <a:endParaRPr lang="en-US" sz="1080" dirty="0"/>
+          </a:p>
+        </p:txBody>
+      </p:sp>
+      <p:sp>
+        <p:nvSpPr>
+          <p:cNvPr id="45" name="Text 43"/>
+          <p:cNvSpPr/>
+          <p:nvPr/>
+        </p:nvSpPr>
+        <p:spPr>
+          <a:xfrm>
+            <a:off x="457200" y="6473952"/>
+            <a:ext cx="5486400" cy="274320"/>
+          </a:xfrm>
+          <a:prstGeom prst="rect">
+            <a:avLst/>
+          </a:prstGeom>
+          <a:noFill/>
+          <a:ln/>
+        </p:spPr>
+        <p:txBody>
+          <a:bodyPr wrap="square" rtlCol="0" anchor="ctr"/>
+          <a:lstStyle/>
+          <a:p>
+            <a:pPr algn="l" indent="0" marL="0">
+              <a:buNone/>
+            </a:pPr>
+            <a:r>
+              <a:rPr lang="en-US" sz="900" dirty="0">
+                <a:solidFill>
+                  <a:srgbClr val="5B6B82"/>
+                </a:solidFill>
+                <a:latin typeface="Calibri" pitchFamily="34" charset="0"/>
+                <a:ea typeface="Calibri" pitchFamily="34" charset="-122"/>
+                <a:cs typeface="Calibri" pitchFamily="34" charset="-120"/>
+              </a:rPr>
               <a:t>15  —  Implementation Roadmap</a:t>
             </a:r>
             <a:endParaRPr lang="en-US" sz="900" dirty="0"/>
@@ -15992,7 +16394,7 @@
       </p:sp>
       <p:sp>
         <p:nvSpPr>
-          <p:cNvPr id="40" name="Text 38"/>
+          <p:cNvPr id="46" name="Text 44"/>
           <p:cNvSpPr/>
           <p:nvPr/>
         </p:nvSpPr>
@@ -16273,31 +16675,70 @@
         </p:nvSpPr>
         <p:spPr>
           <a:xfrm>
-            <a:off x="457200" y="6473952"/>
-            <a:ext cx="5486400" cy="274320"/>
-          </a:xfrm>
-          <a:prstGeom prst="rect">
-            <a:avLst/>
-          </a:prstGeom>
-          <a:noFill/>
-          <a:ln/>
-        </p:spPr>
-        <p:txBody>
-          <a:bodyPr wrap="square" rtlCol="0" anchor="ctr"/>
-          <a:lstStyle/>
-          <a:p>
-            <a:pPr algn="l" indent="0" marL="0">
-              <a:buNone/>
-            </a:pPr>
-            <a:r>
-              <a:rPr lang="en-US" sz="900" dirty="0">
-                <a:solidFill>
-                  <a:srgbClr val="7C8CA8"/>
+            <a:off x="731520" y="4846320"/>
+            <a:ext cx="8229600" cy="320040"/>
+          </a:xfrm>
+          <a:prstGeom prst="rect">
+            <a:avLst/>
+          </a:prstGeom>
+          <a:noFill/>
+          <a:ln/>
+        </p:spPr>
+        <p:txBody>
+          <a:bodyPr wrap="square" lIns="0" tIns="0" rIns="0" bIns="0" rtlCol="0" anchor="ctr"/>
+          <a:lstStyle/>
+          <a:p>
+            <a:pPr indent="0" marL="0">
+              <a:buNone/>
+            </a:pPr>
+            <a:r>
+              <a:rPr lang="en-US" sz="1150" b="1" dirty="0">
+                <a:solidFill>
+                  <a:srgbClr val="21C5A8"/>
                 </a:solidFill>
                 <a:latin typeface="Calibri" pitchFamily="34" charset="0"/>
                 <a:ea typeface="Calibri" pitchFamily="34" charset="-122"/>
                 <a:cs typeface="Calibri" pitchFamily="34" charset="-120"/>
               </a:rPr>
+              <a:t>Iheanyi Okwara  |  Data Analyst</a:t>
+            </a:r>
+            <a:endParaRPr lang="en-US" sz="1150" dirty="0"/>
+          </a:p>
+        </p:txBody>
+      </p:sp>
+      <p:sp>
+        <p:nvSpPr>
+          <p:cNvPr id="9" name="Text 7"/>
+          <p:cNvSpPr/>
+          <p:nvPr/>
+        </p:nvSpPr>
+        <p:spPr>
+          <a:xfrm>
+            <a:off x="457200" y="6473952"/>
+            <a:ext cx="5486400" cy="274320"/>
+          </a:xfrm>
+          <a:prstGeom prst="rect">
+            <a:avLst/>
+          </a:prstGeom>
+          <a:noFill/>
+          <a:ln/>
+        </p:spPr>
+        <p:txBody>
+          <a:bodyPr wrap="square" rtlCol="0" anchor="ctr"/>
+          <a:lstStyle/>
+          <a:p>
+            <a:pPr algn="l" indent="0" marL="0">
+              <a:buNone/>
+            </a:pPr>
+            <a:r>
+              <a:rPr lang="en-US" sz="900" dirty="0">
+                <a:solidFill>
+                  <a:srgbClr val="7C8CA8"/>
+                </a:solidFill>
+                <a:latin typeface="Calibri" pitchFamily="34" charset="0"/>
+                <a:ea typeface="Calibri" pitchFamily="34" charset="-122"/>
+                <a:cs typeface="Calibri" pitchFamily="34" charset="-120"/>
+              </a:rPr>
               <a:t>16  —  Thank You</a:t>
             </a:r>
             <a:endParaRPr lang="en-US" sz="900" dirty="0"/>
@@ -16306,7 +16747,7 @@
       </p:sp>
       <p:sp>
         <p:nvSpPr>
-          <p:cNvPr id="9" name="Text 7"/>
+          <p:cNvPr id="10" name="Text 8"/>
           <p:cNvSpPr/>
           <p:nvPr/>
         </p:nvSpPr>
@@ -16482,7 +16923,7 @@
                 <a:ea typeface="Calibri" pitchFamily="34" charset="-122"/>
                 <a:cs typeface="Calibri" pitchFamily="34" charset="-120"/>
               </a:rPr>
-              <a:t>Across FY2024–FY2025 the network recorded 5,000 outages spanning 500 sites and 5 vendors. Nearly 1 in 5 SLA assessments breached target, and customer-facing impact reached over a million incidents — translating directly into complaints, escalated trouble tickets, and rising maintenance spend.</a:t>
+              <a:t>Across FY2024–FY2025 the network recorded 5,000 outages spanning 500 sites and 5 vendors. Nearly 1 in 5 SLA assessments breached target, and aggregated customer-impact events exceeded 1.08 million — alongside complaints, escalated trouble tickets, and rising maintenance spend.</a:t>
             </a:r>
             <a:endParaRPr lang="en-US" sz="1450" dirty="0"/>
           </a:p>
@@ -16762,7 +17203,7 @@
                 <a:ea typeface="Calibri" pitchFamily="34" charset="-122"/>
                 <a:cs typeface="Calibri" pitchFamily="34" charset="-120"/>
               </a:rPr>
-              <a:t>2,000 complaints and 610 escalated tickets trace back to unresolved outages.</a:t>
+              <a:t>2,000 complaints and 610 escalated tickets highlight the customer-service burden occurring alongside network reliability issues.</a:t>
             </a:r>
             <a:endParaRPr lang="en-US" sz="1150" dirty="0"/>
           </a:p>
@@ -16902,7 +17343,7 @@
                 <a:ea typeface="Calibri" pitchFamily="34" charset="-122"/>
                 <a:cs typeface="Calibri" pitchFamily="34" charset="-120"/>
               </a:rPr>
-              <a:t>£1.07M in maintenance spend, with emergency callouts the least reliable category.</a:t>
+              <a:t>£1.07M in maintenance spend, with emergency callouts showing the lowest completion rate.</a:t>
             </a:r>
             <a:endParaRPr lang="en-US" sz="1150" dirty="0"/>
           </a:p>
@@ -17243,7 +17684,7 @@
                 <a:ea typeface="Calibri" pitchFamily="34" charset="-122"/>
                 <a:cs typeface="Calibri" pitchFamily="34" charset="-120"/>
               </a:rPr>
-              <a:t>Customer impact events</a:t>
+              <a:t>Aggregated customer-impact events</a:t>
             </a:r>
             <a:endParaRPr lang="en-US" sz="1150" dirty="0"/>
           </a:p>
@@ -18057,7 +18498,7 @@
                 <a:ea typeface="Calibri" pitchFamily="34" charset="-122"/>
                 <a:cs typeface="Calibri" pitchFamily="34" charset="-120"/>
               </a:rPr>
-              <a:t>Customer Impact</a:t>
+              <a:t>Aggregated Customer Impact</a:t>
             </a:r>
             <a:endParaRPr lang="en-US" sz="1050" dirty="0"/>
           </a:p>
@@ -21183,7 +21624,7 @@
                 <a:ea typeface="Calibri" pitchFamily="34" charset="-122"/>
                 <a:cs typeface="Calibri" pitchFamily="34" charset="-120"/>
               </a:rPr>
-              <a:t>London accounts for 1,308 outages — 26% of the network total from a single region — and 827.5 of the 3,049 downtime hours (27%). That share is disproportionate to any one-region average (which would sit near 8% across 12 regions), pointing to concentrated density, aging estate, or capacity strain rather than a UK-wide fault pattern.</a:t>
+              <a:t>London accounts for 1,308 outages — 26% of the network total from a single region — and 827.5 of the 3,049 downtime hours (27%). That share is disproportionate to any one-region average (which would sit near 8% across 12 regions), making London a clear regional outlier that warrants deeper investigation into site density, asset condition, capacity and other potential contributing factors.</a:t>
             </a:r>
             <a:endParaRPr lang="en-US" sz="1200" dirty="0"/>
           </a:p>
@@ -21823,7 +22264,7 @@
                 <a:ea typeface="Cambria" pitchFamily="34" charset="-122"/>
                 <a:cs typeface="Cambria" pitchFamily="34" charset="-120"/>
               </a:rPr>
-              <a:t>Compliance Is Climbing — Hardware Still Drives Breaches</a:t>
+              <a:t>Compliance Fluctuates — Hardware Drives Non-Compliance</a:t>
             </a:r>
             <a:endParaRPr lang="en-US" sz="3000" dirty="0"/>
           </a:p>

</xml_diff>